<commit_message>
chore(catalogue): regenerate for 50 skills, and rebuild the deck
The agent-observability skill landed without its generated README, the page's
counts, or an adapter entry — all three come from this one regeneration.

The deck rebuild is where the derived counts paid for themselves on their first
run: platform-devops went from 8 to 9 and now ties software-development at the
top of the discipline chart, which re-sorted itself. Under the old hardcoded
table that bar would have read 4.

The field guide's telemetry section now names the skill it was pointing at
in the abstract, since it exists.

Co-Authored-By: Claude Opus 5 (1M context) <noreply@anthropic.com>
</commit_message>
<xml_diff>
--- a/docs/navi-delivery-overview.pptx
+++ b/docs/navi-delivery-overview.pptx
@@ -520,7 +520,7 @@
           <a:p>
             <a:r>
               <a:rPr lang="en-US" dirty="0"/>
-              <a:t>navi-delivery is built and shipped, not a design. Counts read from the repo at build time: 11 agents, 49 skills across 13 disciplines, 9 phases and gates, 4 lanes, an 8-verb CLI.</a:t>
+              <a:t>navi-delivery is built and shipped, not a design. Counts read from the repo at build time: 11 agents, 50 skills across 13 disciplines, 9 phases and gates, 4 lanes, an 8-verb CLI.</a:t>
             </a:r>
             <a:endParaRPr lang="en-US" dirty="0"/>
           </a:p>
@@ -2822,7 +2822,7 @@
                 <a:ea typeface="Mulish" pitchFamily="34" charset="-122"/>
                 <a:cs typeface="Mulish" pitchFamily="34" charset="-120"/>
               </a:rPr>
-              <a:t>49</a:t>
+              <a:t>50</a:t>
             </a:r>
             <a:endParaRPr lang="en-US" sz="3400" dirty="0"/>
           </a:p>
@@ -12220,7 +12220,7 @@
                 <a:ea typeface="Calibri" pitchFamily="34" charset="-122"/>
                 <a:cs typeface="Calibri" pitchFamily="34" charset="-120"/>
               </a:rPr>
-              <a:t>→ the preferred way in — 49 skills and 11 agents, with no clone</a:t>
+              <a:t>→ the preferred way in — 50 skills and 11 agents, with no clone</a:t>
             </a:r>
             <a:endParaRPr lang="en-US" sz="900" dirty="0"/>
           </a:p>
@@ -17651,7 +17651,7 @@
                 <a:ea typeface="Mulish" pitchFamily="34" charset="-122"/>
                 <a:cs typeface="Mulish" pitchFamily="34" charset="-120"/>
               </a:rPr>
-              <a:t>49</a:t>
+              <a:t>50</a:t>
             </a:r>
             <a:endParaRPr lang="en-US" sz="3000" dirty="0"/>
           </a:p>
@@ -21509,7 +21509,7 @@
                 <a:ea typeface="Calibri" pitchFamily="34" charset="-122"/>
                 <a:cs typeface="Calibri" pitchFamily="34" charset="-120"/>
               </a:rPr>
-              <a:t>49 SKILLS</a:t>
+              <a:t>50 SKILLS</a:t>
             </a:r>
             <a:endParaRPr lang="en-US" sz="1000" dirty="0"/>
           </a:p>
@@ -21689,7 +21689,7 @@
                 <a:ea typeface="Calibri" pitchFamily="34" charset="-122"/>
                 <a:cs typeface="Calibri" pitchFamily="34" charset="-120"/>
               </a:rPr>
-              <a:t>software-development</a:t>
+              <a:t>platform-devops</a:t>
             </a:r>
             <a:endParaRPr lang="en-US" sz="1150" dirty="0"/>
           </a:p>
@@ -21821,7 +21821,7 @@
                 <a:ea typeface="Calibri" pitchFamily="34" charset="-122"/>
                 <a:cs typeface="Calibri" pitchFamily="34" charset="-120"/>
               </a:rPr>
-              <a:t>platform-devops</a:t>
+              <a:t>software-development</a:t>
             </a:r>
             <a:endParaRPr lang="en-US" sz="1150" dirty="0"/>
           </a:p>
@@ -21863,7 +21863,7 @@
         <p:spPr>
           <a:xfrm>
             <a:off x="3063240" y="2350008"/>
-            <a:ext cx="2086051" cy="201168"/>
+            <a:ext cx="2346808" cy="201168"/>
           </a:xfrm>
           <a:prstGeom prst="roundRect">
             <a:avLst>
@@ -21914,7 +21914,7 @@
                 <a:ea typeface="Mulish" pitchFamily="34" charset="-122"/>
                 <a:cs typeface="Mulish" pitchFamily="34" charset="-120"/>
               </a:rPr>
-              <a:t>8</a:t>
+              <a:t>9</a:t>
             </a:r>
             <a:endParaRPr lang="en-US" sz="1150" dirty="0"/>
           </a:p>

</xml_diff>